<commit_message>
zoom audit: JS-positioned popovers and pointer drags now track the cursor at any UI zoom
- shell: fixed elements inside the zoomed root that JS positions in viewport px (fork hover cards,
  portal tool menus, Automation dropdowns, inline position:fixed) get an inverse zoom so their insets
  land where the code meant them
- codex-ui: sidebar width drag and composer width drag divide pointer deltas by the UI zoom

Co-Authored-By: Claude Fable 5.1 <noreply@anthropic.com>
</commit_message>
<xml_diff>
--- a/slide-recap.pptx
+++ b/slide-recap.pptx
@@ -1160,7 +1160,7 @@
         <p:spPr>
           <a:xfrm>
             <a:off x="812800" y="2235200"/>
-            <a:ext cx="8483600" cy="914400"/>
+            <a:ext cx="7721600" cy="914400"/>
           </a:xfrm>
           <a:prstGeom prst="rect">
             <a:avLst/>
@@ -1199,7 +1199,7 @@
                   </a:ext>
                 </a:extLst>
               </a:rPr>
-              <a:t>第三季度销售情况说明。</a:t>
+              <a:t>第三季度销售情况说明</a:t>
             </a:r>
           </a:p>
         </p:txBody>

</xml_diff>

<commit_message>
restore Univer sample artifacts touched by the zoom drag test
Co-Authored-By: Claude Fable 5.1 <noreply@anthropic.com>
</commit_message>
<xml_diff>
--- a/slide-recap.pptx
+++ b/slide-recap.pptx
@@ -1160,7 +1160,7 @@
         <p:spPr>
           <a:xfrm>
             <a:off x="812800" y="2235200"/>
-            <a:ext cx="7721600" cy="914400"/>
+            <a:ext cx="8483600" cy="914400"/>
           </a:xfrm>
           <a:prstGeom prst="rect">
             <a:avLst/>
@@ -1199,7 +1199,7 @@
                   </a:ext>
                 </a:extLst>
               </a:rPr>
-              <a:t>第三季度销售情况说明</a:t>
+              <a:t>第三季度销售情况说明。</a:t>
             </a:r>
           </a:p>
         </p:txBody>

</xml_diff>